<commit_message>
Deck: polish all template section copy
Tightened the problem statement, brief, opportunities/USP, features, process
flow, wireframe and architecture captions, technologies, benchmarking, and
future work for clarity and impact. Reworked the cost slide to cover both the
prototype (near-zero, scale-to-zero) and an indicative production-scale
estimate. Re-exported the PDF; all 16 slides QA'd for fit.

Co-Authored-By: Claude Opus 4.8 <noreply@anthropic.com>
</commit_message>
<xml_diff>
--- a/docs/submission/Savvy-Cart-AI-gTaprobane-Submission.pptx
+++ b/docs/submission/Savvy-Cart-AI-gTaprobane-Submission.pptx
@@ -7140,7 +7140,7 @@
                 </a:solidFill>
                 <a:latin typeface="Google Sans Flex"/>
               </a:rPr>
-              <a:t> A bank’s headline percent rarely covers the whole basket; the real saving is the basket total after each offer’s exclusions, minimum bill, and cap.</a:t>
+              <a:t> A supermarket card’s headline “% off” rarely covers the whole basket, so Sri Lankan shoppers cannot tell what an offer truly saves after its exclusions, minimum bill, and cap.</a:t>
             </a:r>
             <a:endParaRPr sz="1800">
               <a:latin typeface="Google Sans Flex"/>
@@ -7428,26 +7428,17 @@
                 <a:spcPts val="0"/>
               </a:spcBef>
               <a:spcAft>
-                <a:spcPts val="1100"/>
+                <a:spcPts val="600"/>
               </a:spcAft>
             </a:pPr>
             <a:r>
-              <a:rPr sz="1600">
+              <a:rPr sz="1500" b="1">
                 <a:solidFill>
                   <a:srgbClr val="202020"/>
                 </a:solidFill>
                 <a:latin typeface="Arial"/>
               </a:rPr>
-              <a:t>•  </a:t>
-            </a:r>
-            <a:r>
-              <a:rPr sz="1600" b="0">
-                <a:solidFill>
-                  <a:srgbClr val="202020"/>
-                </a:solidFill>
-                <a:latin typeface="Arial"/>
-              </a:rPr>
-              <a:t>Cloud Run scales to zero (min instances 0, max 3): no paid warm instances.</a:t>
+              <a:t>Prototype (evaluation window):</a:t>
             </a:r>
           </a:p>
           <a:p>
@@ -7456,11 +7447,11 @@
                 <a:spcPts val="0"/>
               </a:spcBef>
               <a:spcAft>
-                <a:spcPts val="1100"/>
+                <a:spcPts val="600"/>
               </a:spcAft>
             </a:pPr>
             <a:r>
-              <a:rPr sz="1600">
+              <a:rPr sz="1400">
                 <a:solidFill>
                   <a:srgbClr val="202020"/>
                 </a:solidFill>
@@ -7469,13 +7460,13 @@
               <a:t>•  </a:t>
             </a:r>
             <a:r>
-              <a:rPr sz="1600" b="0">
+              <a:rPr sz="1400" b="0">
                 <a:solidFill>
                   <a:srgbClr val="202020"/>
                 </a:solidFill>
                 <a:latin typeface="Arial"/>
               </a:rPr>
-              <a:t>Gemini Flash traffic is judge-only during evaluation.</a:t>
+              <a:t>Cloud Run scales to zero (min 0, max 3) — no paid warm instances.</a:t>
             </a:r>
           </a:p>
           <a:p>
@@ -7484,11 +7475,11 @@
                 <a:spcPts val="0"/>
               </a:spcBef>
               <a:spcAft>
-                <a:spcPts val="1100"/>
+                <a:spcPts val="600"/>
               </a:spcAft>
             </a:pPr>
             <a:r>
-              <a:rPr sz="1600">
+              <a:rPr sz="1400">
                 <a:solidFill>
                   <a:srgbClr val="202020"/>
                 </a:solidFill>
@@ -7497,13 +7488,13 @@
               <a:t>•  </a:t>
             </a:r>
             <a:r>
-              <a:rPr sz="1600" b="0">
+              <a:rPr sz="1400" b="0">
                 <a:solidFill>
                   <a:srgbClr val="202020"/>
                 </a:solidFill>
                 <a:latin typeface="Arial"/>
               </a:rPr>
-              <a:t>No managed database cost — the prototype runs on committed fixtures.</a:t>
+              <a:t>Gemini Flash traffic is judge-only; no managed-database cost (committed fixtures).</a:t>
             </a:r>
           </a:p>
           <a:p>
@@ -7512,11 +7503,11 @@
                 <a:spcPts val="0"/>
               </a:spcBef>
               <a:spcAft>
-                <a:spcPts val="1100"/>
+                <a:spcPts val="600"/>
               </a:spcAft>
             </a:pPr>
             <a:r>
-              <a:rPr sz="1600">
+              <a:rPr sz="1400">
                 <a:solidFill>
                   <a:srgbClr val="202020"/>
                 </a:solidFill>
@@ -7525,13 +7516,88 @@
               <a:t>•  </a:t>
             </a:r>
             <a:r>
-              <a:rPr sz="1600" b="0">
+              <a:rPr sz="1400" b="0">
                 <a:solidFill>
                   <a:srgbClr val="202020"/>
                 </a:solidFill>
                 <a:latin typeface="Arial"/>
               </a:rPr>
-              <a:t>Estimated spend over the evaluation window: single-digit to low-tens of USD, typically covered by trial credits.</a:t>
+              <a:t>Estimated spend: single-digit to low-tens of USD, typically within trial credits.</a:t>
+            </a:r>
+          </a:p>
+          <a:p>
+            <a:pPr>
+              <a:spcBef>
+                <a:spcPts val="0"/>
+              </a:spcBef>
+              <a:spcAft>
+                <a:spcPts val="600"/>
+              </a:spcAft>
+            </a:pPr>
+            <a:r>
+              <a:rPr sz="1500" b="1">
+                <a:solidFill>
+                  <a:srgbClr val="202020"/>
+                </a:solidFill>
+                <a:latin typeface="Arial"/>
+              </a:rPr>
+              <a:t>At production scale (indicative):</a:t>
+            </a:r>
+          </a:p>
+          <a:p>
+            <a:pPr>
+              <a:spcBef>
+                <a:spcPts val="0"/>
+              </a:spcBef>
+              <a:spcAft>
+                <a:spcPts val="600"/>
+              </a:spcAft>
+            </a:pPr>
+            <a:r>
+              <a:rPr sz="1400">
+                <a:solidFill>
+                  <a:srgbClr val="202020"/>
+                </a:solidFill>
+                <a:latin typeface="Arial"/>
+              </a:rPr>
+              <a:t>•  </a:t>
+            </a:r>
+            <a:r>
+              <a:rPr sz="1400" b="0">
+                <a:solidFill>
+                  <a:srgbClr val="202020"/>
+                </a:solidFill>
+                <a:latin typeface="Arial"/>
+              </a:rPr>
+              <a:t>Cost tracks active households: roughly one Gemini vision call and one explanation per planning session, plus scale-to-zero Cloud Run.</a:t>
+            </a:r>
+          </a:p>
+          <a:p>
+            <a:pPr>
+              <a:spcBef>
+                <a:spcPts val="0"/>
+              </a:spcBef>
+              <a:spcAft>
+                <a:spcPts val="600"/>
+              </a:spcAft>
+            </a:pPr>
+            <a:r>
+              <a:rPr sz="1400">
+                <a:solidFill>
+                  <a:srgbClr val="202020"/>
+                </a:solidFill>
+                <a:latin typeface="Arial"/>
+              </a:rPr>
+              <a:t>•  </a:t>
+            </a:r>
+            <a:r>
+              <a:rPr sz="1400" b="0">
+                <a:solidFill>
+                  <a:srgbClr val="202020"/>
+                </a:solidFill>
+                <a:latin typeface="Arial"/>
+              </a:rPr>
+              <a:t>Add Firestore (sessions, catalog/offer snapshots) and Cloud Storage (receipts): low-tens to low-hundreds of USD per month for an early pilot, before any retailer-data licensing.</a:t>
             </a:r>
           </a:p>
         </p:txBody>
@@ -8046,7 +8112,7 @@
                 </a:solidFill>
                 <a:latin typeface="Arial"/>
               </a:rPr>
-              <a:t>120 automated tests pass — deterministic pricing, offer eligibility, and guardrails.</a:t>
+              <a:t>120 automated tests pass — covering deterministic pricing, offer eligibility, and the grounding guardrails.</a:t>
             </a:r>
           </a:p>
           <a:p>
@@ -8074,7 +8140,7 @@
                 </a:solidFill>
                 <a:latin typeface="Arial"/>
               </a:rPr>
-              <a:t>Live Gemini (18 Oct 2026): the Why answer about 30 seconds; reading a bank offer about 7 seconds.</a:t>
+              <a:t>Live Gemini (checked 18 Oct 2026): the agent’s Why answer about 30 seconds; reading a bank offer about 7 seconds.</a:t>
             </a:r>
           </a:p>
           <a:p>
@@ -8102,7 +8168,7 @@
                 </a:solidFill>
                 <a:latin typeface="Arial"/>
               </a:rPr>
-              <a:t>Worked example (simulated): a default basket costs LKR 4,604 across Keells and Cargills — LKR 1,328 below buying everything at Keells shelf price; the two-store split beats the best single store by LKR 63 (at a LKR 320 trip cost, one store wins).</a:t>
+              <a:t>Worked example (simulated): a default basket costs LKR 4,604 across Keells and Cargills — LKR 1,328 below buying everything at Keells shelf price. The two-store split beats the best single store by only LKR 63, and at a LKR 320 trip cost the optimizer drops to one store.</a:t>
             </a:r>
           </a:p>
           <a:p>
@@ -8130,7 +8196,7 @@
                 </a:solidFill>
                 <a:latin typeface="Arial"/>
               </a:rPr>
-              <a:t>Offer Reality Check: a “10% off Saturday” headline that suggests LKR 593 pays LKR 0 — the basket is LKR 2,475 under the LKR 8,000 minimum.</a:t>
+              <a:t>Offer Reality Check: a “10% off Saturday” headline worth LKR 593 on paper pays LKR 0 — the basket is LKR 2,475 short of the LKR 8,000 minimum.</a:t>
             </a:r>
           </a:p>
           <a:p>
@@ -8158,7 +8224,7 @@
                 </a:solidFill>
                 <a:latin typeface="Arial"/>
               </a:rPr>
-              <a:t>All savings are simulated on labeled sample data.</a:t>
+              <a:t>Every saving is simulated on labeled sample data.</a:t>
             </a:r>
           </a:p>
         </p:txBody>
@@ -8384,7 +8450,7 @@
                 </a:solidFill>
                 <a:latin typeface="Arial"/>
               </a:rPr>
-              <a:t>Roadmap: </a:t>
+              <a:t>Roadmap — </a:t>
             </a:r>
             <a:r>
               <a:rPr sz="1500" b="0">
@@ -8393,7 +8459,7 @@
                 </a:solidFill>
                 <a:latin typeface="Arial"/>
               </a:rPr>
-              <a:t>a Colombo household pilot, then authorized retailer/issuer data feeds (versioned prices, real card terms), then adapting the rules to other JAPAC markets (currencies, rounding, local card offers).</a:t>
+              <a:t>a Colombo household pilot; then authorized retailer and issuer data feeds (versioned prices, real card terms); then adapting the rule engine to other JAPAC markets (currencies, rounding, local card offers).</a:t>
             </a:r>
           </a:p>
           <a:p>
@@ -8421,7 +8487,7 @@
                 </a:solidFill>
                 <a:latin typeface="Arial"/>
               </a:rPr>
-              <a:t>Business model: </a:t>
+              <a:t>Business model — </a:t>
             </a:r>
             <a:r>
               <a:rPr sz="1500" b="0">
@@ -8430,7 +8496,7 @@
                 </a:solidFill>
                 <a:latin typeface="Arial"/>
               </a:rPr>
-              <a:t>a free household tool; later, issuers or retailers pay for consented, disclosed referrals — never selling the shopper’s data.</a:t>
+              <a:t>free for households; later, issuers or retailers pay for consented, disclosed referrals. We never sell the shopper’s data.</a:t>
             </a:r>
           </a:p>
           <a:p>
@@ -8458,7 +8524,7 @@
                 </a:solidFill>
                 <a:latin typeface="Arial"/>
               </a:rPr>
-              <a:t>Beyond the prototype: </a:t>
+              <a:t>Beyond the prototype — </a:t>
             </a:r>
             <a:r>
               <a:rPr sz="1500" b="0">
@@ -9433,7 +9499,7 @@
                 <a:spcPts val="0"/>
               </a:spcBef>
               <a:spcAft>
-                <a:spcPts val="1200"/>
+                <a:spcPts val="1300"/>
               </a:spcAft>
             </a:pPr>
             <a:r>
@@ -9443,7 +9509,7 @@
                 </a:solidFill>
                 <a:latin typeface="Arial"/>
               </a:rPr>
-              <a:t>Savvy Cart AI is a condition-aware grocery basket optimizer for Sri Lankan households. It reads a shopper’s receipts with Gemini, works out what they are running low on, and plans the cheapest </a:t>
+              <a:t>Savvy Cart AI is a condition-aware grocery basket optimizer for Sri Lankan households. Gemini reads a shopper’s receipts and bank offers; deterministic code then plans the cheapest </a:t>
             </a:r>
             <a:r>
               <a:rPr sz="1600" b="1">
@@ -9461,7 +9527,7 @@
                 </a:solidFill>
                 <a:latin typeface="Arial"/>
               </a:rPr>
-              <a:t> way to buy it on a chosen day — across up to four stores, one card per bill — applying every exclusion, minimum bill, cap, and store or card rule in deterministic code, not guessing with a model.</a:t>
+              <a:t> way to buy what they need on a chosen day — across up to four stores, one card per bill — applying every exclusion, minimum bill, cap, and store or card rule in code, never guessing with a model.</a:t>
             </a:r>
           </a:p>
           <a:p>
@@ -9498,7 +9564,7 @@
                 </a:solidFill>
                 <a:latin typeface="Arial"/>
               </a:rPr>
-              <a:t> lets a shopper paste a bank offer and see what the headline promises against what the terms actually pay on their own basket. The app is live on Cloud Run with Gemini and the Agent Development Kit — a guest, no-login, five-step flow that ends in a MOCK approval (no order is sent).</a:t>
+              <a:t> turns a pasted bank offer into what the headline promises versus what the terms actually pay on this shopper’s basket. The app is live on Cloud Run, built with Gemini and the Agent Development Kit: a guest, no-login, five-step flow that ends in a MOCK approval — no order is ever sent.</a:t>
             </a:r>
           </a:p>
         </p:txBody>
@@ -9865,7 +9931,7 @@
                 </a:solidFill>
                 <a:latin typeface="Arial"/>
               </a:rPr>
-              <a:t>price-comparison apps show the cheapest store per item. Savvy Cart prices the full basket after card-offer exclusions, minimums, caps, and cannot-combine rules — and shows, line by line, when a famous “25% off” actually pays LKR 0.</a:t>
+              <a:t>price-comparison apps find the cheapest store per item. Savvy Cart prices the whole basket after card-offer exclusions, minimums, caps, and cannot-combine rules — and shows, line by line, when a famous “25% off” actually pays LKR 0.</a:t>
             </a:r>
           </a:p>
           <a:p>
@@ -9902,7 +9968,7 @@
                 </a:solidFill>
                 <a:latin typeface="Arial"/>
               </a:rPr>
-              <a:t>Gemini turns receipts and offer text into structured data; an exact OR-Tools optimizer assigns items to stores and applies every rule; the shopper sees baseline vs optimized and the best day, then approves. Nothing is auto-ordered.</a:t>
+              <a:t>Gemini turns receipts and offer text into structured data; an exact OR-Tools optimizer assigns each item to a store and applies every rule; the shopper compares baseline vs optimized, sees the best day, and approves. Nothing is auto-ordered.</a:t>
             </a:r>
           </a:p>
           <a:p>
@@ -9939,7 +10005,7 @@
                 </a:solidFill>
                 <a:latin typeface="Arial"/>
               </a:rPr>
-              <a:t>the AI reads documents; deterministic code owns every rupee, so the plan can be trusted. Two grounding layers stop the model inventing a price, discount, or total.</a:t>
+              <a:t>the model reads documents; deterministic code owns every rupee, so the plan is auditable, not a guess. Two grounding layers stop the model inventing a price, discount, or total.</a:t>
             </a:r>
           </a:p>
         </p:txBody>
@@ -10165,7 +10231,7 @@
                 </a:solidFill>
                 <a:latin typeface="Arial"/>
               </a:rPr>
-              <a:t>Receipt-driven pantry: due dates from real purchase history (median gap) — no forecasting model.</a:t>
+              <a:t>Receipt-driven pantry — due dates from real purchase history (median gap), not a forecasting model.</a:t>
             </a:r>
           </a:p>
           <a:p>
@@ -10193,7 +10259,7 @@
                 </a:solidFill>
                 <a:latin typeface="Arial"/>
               </a:rPr>
-              <a:t>Gemini receipt extraction: a photo becomes catalog-matched lines with a confidence per line.</a:t>
+              <a:t>Gemini receipt extraction — a photo becomes catalog-matched lines, each with a confidence score.</a:t>
             </a:r>
           </a:p>
           <a:p>
@@ -10221,7 +10287,7 @@
                 </a:solidFill>
                 <a:latin typeface="Arial"/>
               </a:rPr>
-              <a:t>Offer Reality Check: Gemini reads a bank offer’s text or screenshot into validated terms.</a:t>
+              <a:t>Offer Reality Check — Gemini reads a bank offer’s text or screenshot into validated, editable terms.</a:t>
             </a:r>
           </a:p>
           <a:p>
@@ -10249,7 +10315,7 @@
                 </a:solidFill>
                 <a:latin typeface="Arial"/>
               </a:rPr>
-              <a:t>Exact multi-store optimizer (OR-Tools CP-SAT): up to four stores, store promotions, one card offer per bill, trip-cost aware.</a:t>
+              <a:t>Exact multi-store optimizer (OR-Tools CP-SAT) — up to four stores, store promotions, one card offer per bill, and the cost of an extra trip.</a:t>
             </a:r>
           </a:p>
           <a:p>
@@ -10277,7 +10343,7 @@
                 </a:solidFill>
                 <a:latin typeface="Arial"/>
               </a:rPr>
-              <a:t>Ask the agent (ADK): natural-language questions, on-demand re-planning, and a visible tool trace.</a:t>
+              <a:t>Ask the agent (ADK) — natural-language questions, on-demand re-planning, and a visible tool trace.</a:t>
             </a:r>
           </a:p>
           <a:p>
@@ -10305,7 +10371,7 @@
                 </a:solidFill>
                 <a:latin typeface="Arial"/>
               </a:rPr>
-              <a:t>Honest by design: “this offer refuses your basket” (LKR 0), no invented numbers, MOCK approval, and no card numbers ever.</a:t>
+              <a:t>Honest by design — it says “this offer pays LKR 0”, invents no numbers, previews a MOCK order, and never touches a card number.</a:t>
             </a:r>
           </a:p>
         </p:txBody>
@@ -10522,7 +10588,7 @@
                 </a:solidFill>
                 <a:latin typeface="Arial"/>
               </a:rPr>
-              <a:t>Guest opens the Cloud Run URL — no login — and moves through a five-step wizard:</a:t>
+              <a:t>A guest opens the Cloud Run URL — no login — and moves through a five-step wizard:</a:t>
             </a:r>
           </a:p>
           <a:p>
@@ -10559,7 +10625,7 @@
                 </a:solidFill>
                 <a:latin typeface="Arial"/>
               </a:rPr>
-              <a:t>receipt history shows what is running low; add a receipt (sample, or a photo read by Gemini).</a:t>
+              <a:t>receipt history shows what is running low; add a receipt (the sample, or a photo read by Gemini).</a:t>
             </a:r>
           </a:p>
           <a:p>
@@ -10596,7 +10662,7 @@
                 </a:solidFill>
                 <a:latin typeface="Arial"/>
               </a:rPr>
-              <a:t>choose cards, stores, and trip cost; run Offer Reality Check on a bank offer.</a:t>
+              <a:t>choose cards, stores, and trip cost; run Offer Reality Check on any bank offer.</a:t>
             </a:r>
           </a:p>
           <a:p>
@@ -10633,7 +10699,7 @@
                 </a:solidFill>
                 <a:latin typeface="Arial"/>
               </a:rPr>
-              <a:t>the OR-Tools optimizer picks stores, store promotions, the best card offer, and the best day.</a:t>
+              <a:t>the OR-Tools optimizer picks the stores, store promotions, best card offer, and best day.</a:t>
             </a:r>
           </a:p>
           <a:p>
@@ -10670,7 +10736,7 @@
                 </a:solidFill>
                 <a:latin typeface="Arial"/>
               </a:rPr>
-              <a:t>the ADK agent explains the plan, can re-plan, and shows every tool call it made.</a:t>
+              <a:t>the ADK agent explains the plan, re-plans on request, and shows every tool call it made.</a:t>
             </a:r>
           </a:p>
           <a:p>
@@ -10948,7 +11014,7 @@
                 </a:solidFill>
                 <a:latin typeface="Arial"/>
               </a:rPr>
-              <a:t>The deployed guest UI is the working prototype. Shown: the </a:t>
+              <a:t>The deployed guest UI is the working prototype — these are live screens, not mockups. Shown: the </a:t>
             </a:r>
             <a:r>
               <a:rPr sz="1400" b="1">
@@ -10966,7 +11032,7 @@
                 </a:solidFill>
                 <a:latin typeface="Arial"/>
               </a:rPr>
-              <a:t> step, where the ADK agent answers the shopper’s question in natural language and shows every tool call it made (plan_day, explain_plan_numbers). Every number is checked against the engine before it is displayed.</a:t>
+              <a:t> step, where the ADK agent answers the shopper’s question in plain language and reveals every tool call it made (plan_day, explain_plan_numbers). Every figure is checked against the engine before it appears.</a:t>
             </a:r>
           </a:p>
         </p:txBody>
@@ -11433,7 +11499,7 @@
                 </a:solidFill>
                 <a:latin typeface="Arial"/>
               </a:rPr>
-              <a:t>Google Cloud: </a:t>
+              <a:t>Google Cloud — </a:t>
             </a:r>
             <a:r>
               <a:rPr sz="1500" b="0">
@@ -11442,7 +11508,7 @@
                 </a:solidFill>
                 <a:latin typeface="Arial"/>
               </a:rPr>
-              <a:t>Cloud Run (asia-southeast1, scale to zero), Gemini gemini-3.8-flash on the Gemini Enterprise Agent Platform, Secret Manager.</a:t>
+              <a:t>Cloud Run (asia-southeast1, scale-to-zero); Gemini gemini-3.8-flash on the Gemini Enterprise Agent Platform; Secret Manager.</a:t>
             </a:r>
           </a:p>
           <a:p>
@@ -11470,7 +11536,7 @@
                 </a:solidFill>
                 <a:latin typeface="Arial"/>
               </a:rPr>
-              <a:t>GenAI &amp; agents: </a:t>
+              <a:t>GenAI &amp; agents — </a:t>
             </a:r>
             <a:r>
               <a:rPr sz="1500" b="0">
@@ -11507,7 +11573,7 @@
                 </a:solidFill>
                 <a:latin typeface="Arial"/>
               </a:rPr>
-              <a:t>Optimization: </a:t>
+              <a:t>Optimization — </a:t>
             </a:r>
             <a:r>
               <a:rPr sz="1500" b="0">
@@ -11544,7 +11610,7 @@
                 </a:solidFill>
                 <a:latin typeface="Arial"/>
               </a:rPr>
-              <a:t>Application: </a:t>
+              <a:t>Application — </a:t>
             </a:r>
             <a:r>
               <a:rPr sz="1500" b="0">
@@ -11553,7 +11619,7 @@
                 </a:solidFill>
                 <a:latin typeface="Arial"/>
               </a:rPr>
-              <a:t>Python 3.12, FastAPI, uvicorn; server-rendered HTML with a small vanilla JS/CSS frontend; httpx.</a:t>
+              <a:t>Python 3.12, FastAPI, uvicorn; server-rendered HTML with a lightweight vanilla JS/CSS frontend; httpx.</a:t>
             </a:r>
           </a:p>
           <a:p>
@@ -11581,7 +11647,7 @@
                 </a:solidFill>
                 <a:latin typeface="Arial"/>
               </a:rPr>
-              <a:t>Build &amp; test: </a:t>
+              <a:t>Build &amp; test — </a:t>
             </a:r>
             <a:r>
               <a:rPr sz="1500" b="0">
@@ -11590,7 +11656,7 @@
                 </a:solidFill>
                 <a:latin typeface="Arial"/>
               </a:rPr>
-              <a:t>Docker (python:3.12-slim, non-root); pytest — 120 passing.</a:t>
+              <a:t>Docker (python:3.12-slim, non-root); pytest — 120 tests passing.</a:t>
             </a:r>
           </a:p>
           <a:p>
@@ -11618,7 +11684,7 @@
                 </a:solidFill>
                 <a:latin typeface="Arial"/>
               </a:rPr>
-              <a:t>Not used in the prototype: </a:t>
+              <a:t>Not used in the prototype — </a:t>
             </a:r>
             <a:r>
               <a:rPr sz="1500" b="0">
@@ -11627,7 +11693,7 @@
                 </a:solidFill>
                 <a:latin typeface="Arial"/>
               </a:rPr>
-              <a:t>Firebase and Firestore — data is committed fixtures; Firestore is the documented path for production scale.</a:t>
+              <a:t>Firebase and Firestore; the demo runs on committed fixtures, with Firestore as the documented path to production scale.</a:t>
             </a:r>
           </a:p>
         </p:txBody>

</xml_diff>